<commit_message>
highlighting in 3.0.0 pptx
</commit_message>
<xml_diff>
--- a/v3.0.0/Prozente_Tool_250603.pptx
+++ b/v3.0.0/Prozente_Tool_250603.pptx
@@ -137,6 +137,35 @@
 <p188:authorLst xmlns:a="http://schemas.openxmlformats.org/drawingml/2006/main" xmlns:r="http://schemas.openxmlformats.org/officeDocument/2006/relationships" xmlns:p188="http://schemas.microsoft.com/office/powerpoint/2018/8/main">
   <p188:author id="{477A2804-A422-83DE-D2BB-A8E394F80F7A}" name="Marcus Röhming" initials="MR" userId="0f725a30e114f0f8" providerId="Windows Live"/>
 </p188:authorLst>
+</file>
+
+<file path=ppt/changesInfos/changesInfo1.xml><?xml version="1.0" encoding="utf-8"?>
+<pc:chgInfo xmlns:a="http://schemas.openxmlformats.org/drawingml/2006/main" xmlns:r="http://schemas.openxmlformats.org/officeDocument/2006/relationships" xmlns:ac="http://schemas.microsoft.com/office/drawing/2013/main/command" xmlns:pc="http://schemas.microsoft.com/office/powerpoint/2013/main/command">
+  <pc:docChgLst>
+    <pc:chgData name="Marcus Röhming" userId="0f725a30e114f0f8" providerId="LiveId" clId="{E60D6D68-0268-47C9-88E6-3C41BFC3426C}"/>
+    <pc:docChg chg="modSld">
+      <pc:chgData name="Marcus Röhming" userId="0f725a30e114f0f8" providerId="LiveId" clId="{E60D6D68-0268-47C9-88E6-3C41BFC3426C}" dt="2025-06-13T10:33:38.562" v="6" actId="13926"/>
+      <pc:docMkLst>
+        <pc:docMk/>
+      </pc:docMkLst>
+      <pc:sldChg chg="modSp mod">
+        <pc:chgData name="Marcus Röhming" userId="0f725a30e114f0f8" providerId="LiveId" clId="{E60D6D68-0268-47C9-88E6-3C41BFC3426C}" dt="2025-06-13T10:33:38.562" v="6" actId="13926"/>
+        <pc:sldMkLst>
+          <pc:docMk/>
+          <pc:sldMk cId="3333230359" sldId="263"/>
+        </pc:sldMkLst>
+        <pc:spChg chg="mod">
+          <ac:chgData name="Marcus Röhming" userId="0f725a30e114f0f8" providerId="LiveId" clId="{E60D6D68-0268-47C9-88E6-3C41BFC3426C}" dt="2025-06-13T10:33:38.562" v="6" actId="13926"/>
+          <ac:spMkLst>
+            <pc:docMk/>
+            <pc:sldMk cId="3333230359" sldId="263"/>
+            <ac:spMk id="2" creationId="{00000000-0000-0000-0000-000000000000}"/>
+          </ac:spMkLst>
+        </pc:spChg>
+      </pc:sldChg>
+    </pc:docChg>
+  </pc:docChgLst>
+</pc:chgInfo>
 </file>
 
 <file path=ppt/comments/modernComment_106_E0AB6C79.xml><?xml version="1.0" encoding="utf-8"?>
@@ -6288,7 +6317,11 @@
               <a:buChar char="•"/>
             </a:pPr>
             <a:r>
-              <a:rPr lang="de-DE" sz="1600" dirty="0"/>
+              <a:rPr lang="de-DE" sz="1600" dirty="0">
+                <a:highlight>
+                  <a:srgbClr val="00FF00"/>
+                </a:highlight>
+              </a:rPr>
               <a:t>Teile umbenennen in „Schritte“</a:t>
             </a:r>
           </a:p>
@@ -6298,15 +6331,27 @@
               <a:buChar char="•"/>
             </a:pPr>
             <a:r>
-              <a:rPr lang="de-DE" sz="1600" dirty="0"/>
+              <a:rPr lang="de-DE" sz="1600" dirty="0">
+                <a:highlight>
+                  <a:srgbClr val="00FF00"/>
+                </a:highlight>
+              </a:rPr>
               <a:t>Skalierungsoption des ganzen Tools (ist es einstellbar, wie groß das ganze Tool in </a:t>
             </a:r>
             <a:r>
-              <a:rPr lang="de-DE" sz="1600" dirty="0" err="1"/>
+              <a:rPr lang="de-DE" sz="1600" dirty="0" err="1">
+                <a:highlight>
+                  <a:srgbClr val="00FF00"/>
+                </a:highlight>
+              </a:rPr>
               <a:t>Articulate</a:t>
             </a:r>
             <a:r>
-              <a:rPr lang="de-DE" sz="1600" dirty="0"/>
+              <a:rPr lang="de-DE" sz="1600" dirty="0">
+                <a:highlight>
+                  <a:srgbClr val="00FF00"/>
+                </a:highlight>
+              </a:rPr>
               <a:t> angezeigt wird?)</a:t>
             </a:r>
           </a:p>
@@ -6316,14 +6361,26 @@
               <a:buChar char="•"/>
             </a:pPr>
             <a:r>
-              <a:rPr lang="de-DE" sz="1600" dirty="0"/>
+              <a:rPr lang="de-DE" sz="1600" dirty="0">
+                <a:highlight>
+                  <a:srgbClr val="00FF00"/>
+                </a:highlight>
+              </a:rPr>
               <a:t>Standardeinstellungen des Tools, wenn man es öffnet: </a:t>
             </a:r>
             <a:br>
-              <a:rPr lang="de-DE" sz="1600" dirty="0"/>
+              <a:rPr lang="de-DE" sz="1600" dirty="0">
+                <a:highlight>
+                  <a:srgbClr val="00FF00"/>
+                </a:highlight>
+              </a:rPr>
             </a:br>
             <a:r>
-              <a:rPr lang="de-DE" sz="1600" dirty="0"/>
+              <a:rPr lang="de-DE" sz="1600" dirty="0">
+                <a:highlight>
+                  <a:srgbClr val="00FF00"/>
+                </a:highlight>
+              </a:rPr>
               <a:t>Anteil auf 0 und Grundwert auf 0</a:t>
             </a:r>
           </a:p>
@@ -6333,7 +6390,11 @@
               <a:buChar char="•"/>
             </a:pPr>
             <a:r>
-              <a:rPr lang="de-DE" sz="1600" dirty="0"/>
+              <a:rPr lang="de-DE" sz="1600" dirty="0">
+                <a:highlight>
+                  <a:srgbClr val="00FF00"/>
+                </a:highlight>
+              </a:rPr>
               <a:t>Einstellung des Anteils beim Öffnen des Tools: </a:t>
             </a:r>
           </a:p>
@@ -6344,6 +6405,9 @@
             </a:pPr>
             <a:r>
               <a:rPr lang="de-DE" sz="1600" dirty="0">
+                <a:highlight>
+                  <a:srgbClr val="00FF00"/>
+                </a:highlight>
                 <a:latin typeface="Be Vietnam" panose="00000500000000000000" pitchFamily="2" charset="0"/>
               </a:rPr>
               <a:t>Können wir als Admins einen Anteil schon voreinstellen auf z.B. 20 %, sodass es beim Öffnen direkt so angezeigt wird? Von dort aus können die Lernenden dann den Anteil verändern/ weiterziehen etc. </a:t>
@@ -6356,6 +6420,9 @@
             </a:pPr>
             <a:r>
               <a:rPr lang="de-DE" sz="1600" dirty="0">
+                <a:highlight>
+                  <a:srgbClr val="00FFFF"/>
+                </a:highlight>
                 <a:latin typeface="Be Vietnam" panose="00000500000000000000" pitchFamily="2" charset="0"/>
               </a:rPr>
               <a:t>Könnte man im Hintergrund auch den Anteil sperren, dass Lernende das nicht mehr verändern können?</a:t>
@@ -6367,7 +6434,11 @@
               <a:buChar char="•"/>
             </a:pPr>
             <a:r>
-              <a:rPr lang="de-DE" sz="1600" dirty="0"/>
+              <a:rPr lang="de-DE" sz="1600" dirty="0">
+                <a:highlight>
+                  <a:srgbClr val="00FFFF"/>
+                </a:highlight>
+              </a:rPr>
               <a:t>Derzeit wird beim Öffnen 0 MB, 0%, 100 % immer direkt angezeigt. </a:t>
             </a:r>
           </a:p>
@@ -6378,6 +6449,9 @@
             </a:pPr>
             <a:r>
               <a:rPr lang="de-DE" sz="1800" dirty="0">
+                <a:highlight>
+                  <a:srgbClr val="00FFFF"/>
+                </a:highlight>
                 <a:latin typeface="Be Vietnam" panose="00000500000000000000" pitchFamily="2" charset="0"/>
               </a:rPr>
               <a:t>Können wir das im Hintergrund ausschalten für bestimmte Aufgaben, bzw. nur einzelne dieser Werte anzeigen? </a:t>
@@ -6391,7 +6465,7 @@
             <a:r>
               <a:rPr lang="de-DE" sz="1800" dirty="0">
                 <a:highlight>
-                  <a:srgbClr val="FFFF00"/>
+                  <a:srgbClr val="00FFFF"/>
                 </a:highlight>
                 <a:latin typeface="Be Vietnam" panose="00000500000000000000" pitchFamily="2" charset="0"/>
               </a:rPr>

</xml_diff>

<commit_message>
update percentagebar, some general fixe
</commit_message>
<xml_diff>
--- a/v3.0.0/Prozente_Tool_250603.pptx
+++ b/v3.0.0/Prozente_Tool_250603.pptx
@@ -143,11 +143,26 @@
 <pc:chgInfo xmlns:a="http://schemas.openxmlformats.org/drawingml/2006/main" xmlns:r="http://schemas.openxmlformats.org/officeDocument/2006/relationships" xmlns:ac="http://schemas.microsoft.com/office/drawing/2013/main/command" xmlns:pc="http://schemas.microsoft.com/office/powerpoint/2013/main/command">
   <pc:docChgLst>
     <pc:chgData name="Marcus Röhming" userId="0f725a30e114f0f8" providerId="LiveId" clId="{E60D6D68-0268-47C9-88E6-3C41BFC3426C}"/>
-    <pc:docChg chg="modSld">
-      <pc:chgData name="Marcus Röhming" userId="0f725a30e114f0f8" providerId="LiveId" clId="{E60D6D68-0268-47C9-88E6-3C41BFC3426C}" dt="2025-06-13T10:33:38.562" v="6" actId="13926"/>
+    <pc:docChg chg="custSel modSld">
+      <pc:chgData name="Marcus Röhming" userId="0f725a30e114f0f8" providerId="LiveId" clId="{E60D6D68-0268-47C9-88E6-3C41BFC3426C}" dt="2025-06-16T22:03:06.126" v="18" actId="13926"/>
       <pc:docMkLst>
         <pc:docMk/>
       </pc:docMkLst>
+      <pc:sldChg chg="modSp mod">
+        <pc:chgData name="Marcus Röhming" userId="0f725a30e114f0f8" providerId="LiveId" clId="{E60D6D68-0268-47C9-88E6-3C41BFC3426C}" dt="2025-06-16T12:17:07.718" v="15" actId="13926"/>
+        <pc:sldMkLst>
+          <pc:docMk/>
+          <pc:sldMk cId="3769330809" sldId="262"/>
+        </pc:sldMkLst>
+        <pc:spChg chg="mod">
+          <ac:chgData name="Marcus Röhming" userId="0f725a30e114f0f8" providerId="LiveId" clId="{E60D6D68-0268-47C9-88E6-3C41BFC3426C}" dt="2025-06-16T12:17:07.718" v="15" actId="13926"/>
+          <ac:spMkLst>
+            <pc:docMk/>
+            <pc:sldMk cId="3769330809" sldId="262"/>
+            <ac:spMk id="2" creationId="{00000000-0000-0000-0000-000000000000}"/>
+          </ac:spMkLst>
+        </pc:spChg>
+      </pc:sldChg>
       <pc:sldChg chg="modSp mod">
         <pc:chgData name="Marcus Röhming" userId="0f725a30e114f0f8" providerId="LiveId" clId="{E60D6D68-0268-47C9-88E6-3C41BFC3426C}" dt="2025-06-13T10:33:38.562" v="6" actId="13926"/>
         <pc:sldMkLst>
@@ -159,6 +174,36 @@
           <ac:spMkLst>
             <pc:docMk/>
             <pc:sldMk cId="3333230359" sldId="263"/>
+            <ac:spMk id="2" creationId="{00000000-0000-0000-0000-000000000000}"/>
+          </ac:spMkLst>
+        </pc:spChg>
+      </pc:sldChg>
+      <pc:sldChg chg="modSp mod">
+        <pc:chgData name="Marcus Röhming" userId="0f725a30e114f0f8" providerId="LiveId" clId="{E60D6D68-0268-47C9-88E6-3C41BFC3426C}" dt="2025-06-16T22:03:06.126" v="18" actId="13926"/>
+        <pc:sldMkLst>
+          <pc:docMk/>
+          <pc:sldMk cId="1976073222" sldId="264"/>
+        </pc:sldMkLst>
+        <pc:spChg chg="mod">
+          <ac:chgData name="Marcus Röhming" userId="0f725a30e114f0f8" providerId="LiveId" clId="{E60D6D68-0268-47C9-88E6-3C41BFC3426C}" dt="2025-06-16T22:03:06.126" v="18" actId="13926"/>
+          <ac:spMkLst>
+            <pc:docMk/>
+            <pc:sldMk cId="1976073222" sldId="264"/>
+            <ac:spMk id="2" creationId="{00000000-0000-0000-0000-000000000000}"/>
+          </ac:spMkLst>
+        </pc:spChg>
+      </pc:sldChg>
+      <pc:sldChg chg="modSp mod">
+        <pc:chgData name="Marcus Röhming" userId="0f725a30e114f0f8" providerId="LiveId" clId="{E60D6D68-0268-47C9-88E6-3C41BFC3426C}" dt="2025-06-16T10:52:33.229" v="13" actId="13926"/>
+        <pc:sldMkLst>
+          <pc:docMk/>
+          <pc:sldMk cId="1663545145" sldId="266"/>
+        </pc:sldMkLst>
+        <pc:spChg chg="mod">
+          <ac:chgData name="Marcus Röhming" userId="0f725a30e114f0f8" providerId="LiveId" clId="{E60D6D68-0268-47C9-88E6-3C41BFC3426C}" dt="2025-06-16T10:52:33.229" v="13" actId="13926"/>
+          <ac:spMkLst>
+            <pc:docMk/>
+            <pc:sldMk cId="1663545145" sldId="266"/>
             <ac:spMk id="2" creationId="{00000000-0000-0000-0000-000000000000}"/>
           </ac:spMkLst>
         </pc:spChg>
@@ -6588,7 +6633,11 @@
               <a:buChar char="•"/>
             </a:pPr>
             <a:r>
-              <a:rPr lang="de-DE" sz="1600" dirty="0"/>
+              <a:rPr lang="de-DE" sz="1600" dirty="0">
+                <a:highlight>
+                  <a:srgbClr val="00FF00"/>
+                </a:highlight>
+              </a:rPr>
               <a:t>Derzeit wird Prozentwert (hier 357 MB) und Prozentsatz (50 %) links und rechts neben dem roten Anteil angezeigt. Prozentsatz sollte über den Balken und Prozentwert darunter angezeigt werden und mitwandern beim Verändern wie gehabt. </a:t>
             </a:r>
           </a:p>
@@ -6641,17 +6690,17 @@
             </a:pPr>
             <a:r>
               <a:rPr lang="de-DE" sz="1600" dirty="0">
-                <a:solidFill>
-                  <a:schemeClr val="accent6"/>
-                </a:solidFill>
+                <a:highlight>
+                  <a:srgbClr val="00FF00"/>
+                </a:highlight>
               </a:rPr>
               <a:t>Einheit bei Grundwert und Prozentwert muss für uns im Hintergrund anpassbar sein (hatten wir schon mal drüber gesprochen, z.B. MB, €, kg etc. )</a:t>
             </a:r>
             <a:r>
               <a:rPr lang="de-DE" dirty="0">
-                <a:solidFill>
-                  <a:schemeClr val="accent6"/>
-                </a:solidFill>
+                <a:highlight>
+                  <a:srgbClr val="00FF00"/>
+                </a:highlight>
               </a:rPr>
               <a:t> </a:t>
             </a:r>
@@ -6663,16 +6712,16 @@
             </a:pPr>
             <a:r>
               <a:rPr lang="de-DE" dirty="0">
-                <a:solidFill>
-                  <a:schemeClr val="accent6"/>
-                </a:solidFill>
+                <a:highlight>
+                  <a:srgbClr val="00FF00"/>
+                </a:highlight>
               </a:rPr>
               <a:t>Die Anzeige 0,5 links unten im Streifen muss weg</a:t>
             </a:r>
             <a:endParaRPr lang="de-DE" sz="1600" dirty="0">
-              <a:solidFill>
-                <a:schemeClr val="accent6"/>
-              </a:solidFill>
+              <a:highlight>
+                <a:srgbClr val="00FF00"/>
+              </a:highlight>
             </a:endParaRPr>
           </a:p>
           <a:p>
@@ -6682,25 +6731,25 @@
             </a:pPr>
             <a:r>
               <a:rPr lang="de-DE" sz="1600" dirty="0">
-                <a:solidFill>
-                  <a:schemeClr val="accent6"/>
-                </a:solidFill>
+                <a:highlight>
+                  <a:srgbClr val="00FF00"/>
+                </a:highlight>
               </a:rPr>
               <a:t>Prozentstreifen etwas „</a:t>
             </a:r>
             <a:r>
               <a:rPr lang="de-DE" sz="1600" dirty="0" err="1">
-                <a:solidFill>
-                  <a:schemeClr val="accent6"/>
-                </a:solidFill>
+                <a:highlight>
+                  <a:srgbClr val="00FF00"/>
+                </a:highlight>
               </a:rPr>
               <a:t>schmaller</a:t>
             </a:r>
             <a:r>
               <a:rPr lang="de-DE" sz="1600" dirty="0">
-                <a:solidFill>
-                  <a:schemeClr val="accent6"/>
-                </a:solidFill>
+                <a:highlight>
+                  <a:srgbClr val="00FF00"/>
+                </a:highlight>
               </a:rPr>
               <a:t>“ in der Höhe, und etwas länger</a:t>
             </a:r>
@@ -6712,11 +6761,11 @@
             </a:pPr>
             <a:r>
               <a:rPr lang="de-DE" sz="1600" dirty="0">
-                <a:solidFill>
-                  <a:schemeClr val="accent6"/>
-                </a:solidFill>
+                <a:highlight>
+                  <a:srgbClr val="00FF00"/>
+                </a:highlight>
               </a:rPr>
-              <a:t>Dicke Striche links und rechts müssen dünner. </a:t>
+              <a:t>R Dicke Striche links und rechts müssen dünner. </a:t>
             </a:r>
           </a:p>
           <a:p>
@@ -6866,7 +6915,11 @@
               <a:buChar char="•"/>
             </a:pPr>
             <a:r>
-              <a:rPr lang="de-DE" dirty="0"/>
+              <a:rPr lang="de-DE" dirty="0">
+                <a:highlight>
+                  <a:srgbClr val="00FF00"/>
+                </a:highlight>
+              </a:rPr>
               <a:t>An Grundwert – Eingabefeld auch „-“ und „+“ ergänzen, um Grundwert schrittweise zu verändern (analog wie bei Schritten)</a:t>
             </a:r>
           </a:p>
@@ -6903,6 +6956,9 @@
                 <a:solidFill>
                   <a:srgbClr val="FF0000"/>
                 </a:solidFill>
+                <a:highlight>
+                  <a:srgbClr val="00FF00"/>
+                </a:highlight>
               </a:rPr>
               <a:t>Die Funktion mit den Bögen ist richtig schön! Danke dafür </a:t>
             </a:r>
@@ -6911,6 +6967,9 @@
                 <a:solidFill>
                   <a:srgbClr val="FF0000"/>
                 </a:solidFill>
+                <a:highlight>
+                  <a:srgbClr val="00FF00"/>
+                </a:highlight>
                 <a:sym typeface="Wingdings" panose="05000000000000000000" pitchFamily="2" charset="2"/>
               </a:rPr>
               <a:t> </a:t>
@@ -6920,6 +6979,9 @@
                 <a:solidFill>
                   <a:srgbClr val="FF0000"/>
                 </a:solidFill>
+                <a:highlight>
+                  <a:srgbClr val="00FF00"/>
+                </a:highlight>
               </a:rPr>
               <a:t> Bisher funktioniert die nur für die </a:t>
             </a:r>
@@ -6928,6 +6990,9 @@
                 <a:solidFill>
                   <a:srgbClr val="FF0000"/>
                 </a:solidFill>
+                <a:highlight>
+                  <a:srgbClr val="00FF00"/>
+                </a:highlight>
               </a:rPr>
               <a:t>Schrittigkeit</a:t>
             </a:r>
@@ -6936,6 +7001,9 @@
                 <a:solidFill>
                   <a:srgbClr val="FF0000"/>
                 </a:solidFill>
+                <a:highlight>
+                  <a:srgbClr val="00FF00"/>
+                </a:highlight>
               </a:rPr>
               <a:t> 5, das ist vermutlich ein Bug?</a:t>
             </a:r>
@@ -7077,6 +7145,9 @@
                 <a:solidFill>
                   <a:srgbClr val="FF0000"/>
                 </a:solidFill>
+                <a:highlight>
+                  <a:srgbClr val="00FF00"/>
+                </a:highlight>
               </a:rPr>
               <a:t>Auch für Prozentwert und Prozentsatz soll es ein Eingabefeld geben wie bei dem Grundwert (mit – und + wie bei Grundwert)</a:t>
             </a:r>
@@ -7116,7 +7187,11 @@
               <a:buChar char="•"/>
             </a:pPr>
             <a:r>
-              <a:rPr lang="de-DE" dirty="0"/>
+              <a:rPr lang="de-DE" dirty="0">
+                <a:highlight>
+                  <a:srgbClr val="00FF00"/>
+                </a:highlight>
+              </a:rPr>
               <a:t>Anzeige von Grundwert muss am Streifen ausschaltbar sein über Button (so wie jetzt schon bei Prozentsatz und Prozentwert)</a:t>
             </a:r>
           </a:p>
@@ -7126,7 +7201,11 @@
               <a:buChar char="•"/>
             </a:pPr>
             <a:r>
-              <a:rPr lang="de-DE" dirty="0"/>
+              <a:rPr lang="de-DE" dirty="0">
+                <a:highlight>
+                  <a:srgbClr val="00FF00"/>
+                </a:highlight>
+              </a:rPr>
               <a:t>Eingabefelder für Prozentwert, Prozentsatz und Grundwert (gelbe Felder rechts unten) müssen ebenfalls auf unsichtbar schaltbar/ ausschaltbar sein (ebenfalls über Button, d.h. wir brauchen hier drei Buttons mehr)</a:t>
             </a:r>
           </a:p>

</xml_diff>